<commit_message>
Fiex a problem with the for implementation of fib.
</commit_message>
<xml_diff>
--- a/Slides/unit_7_prog_4.pptx
+++ b/Slides/unit_7_prog_4.pptx
@@ -305,7 +305,7 @@
       </p15:sldGuideLst>
     </p:ext>
     <p:ext uri="http://customooxmlschemas.google.com/">
-      <go:slidesCustomData xmlns="" xmlns:mc="http://schemas.openxmlformats.org/markup-compatibility/2006" xmlns:mv="urn:schemas-microsoft-com:mac:vml" xmlns:c="http://schemas.openxmlformats.org/drawingml/2006/chart" xmlns:dgm="http://schemas.openxmlformats.org/drawingml/2006/diagram" xmlns:o="urn:schemas-microsoft-com:office:office" xmlns:v="urn:schemas-microsoft-com:vml" xmlns:pvml="urn:schemas-microsoft-com:office:powerpoint" xmlns:com="http://schemas.openxmlformats.org/drawingml/2006/compatibility" xmlns:p14="http://schemas.microsoft.com/office/powerpoint/2010/main" xmlns:p15="http://schemas.microsoft.com/office/powerpoint/2012/main" xmlns:ahyp="http://schemas.microsoft.com/office/drawing/2018/hyperlinkcolor" xmlns:go="http://customooxmlschemas.google.com/" r:id="rId80" roundtripDataSignature="AMtx7milieXwv5OUJdQk1cj/252aZuXcIQ=="/>
+      <go:slidesCustomData xmlns:go="http://customooxmlschemas.google.com/" xmlns:ahyp="http://schemas.microsoft.com/office/drawing/2018/hyperlinkcolor" xmlns:p15="http://schemas.microsoft.com/office/powerpoint/2012/main" xmlns:p14="http://schemas.microsoft.com/office/powerpoint/2010/main" xmlns:com="http://schemas.openxmlformats.org/drawingml/2006/compatibility" xmlns:pvml="urn:schemas-microsoft-com:office:powerpoint" xmlns:v="urn:schemas-microsoft-com:vml" xmlns:o="urn:schemas-microsoft-com:office:office" xmlns:dgm="http://schemas.openxmlformats.org/drawingml/2006/diagram" xmlns:c="http://schemas.openxmlformats.org/drawingml/2006/chart" xmlns:mv="urn:schemas-microsoft-com:mac:vml" xmlns:mc="http://schemas.openxmlformats.org/markup-compatibility/2006" xmlns="" r:id="rId80" roundtripDataSignature="AMtx7milieXwv5OUJdQk1cj/252aZuXcIQ=="/>
     </p:ext>
   </p:extLst>
 </p:presentation>
@@ -314,7 +314,7 @@
 <file path=ppt/revisionInfo.xml><?xml version="1.0" encoding="utf-8"?>
 <p1510:revInfo xmlns:a="http://schemas.openxmlformats.org/drawingml/2006/main" xmlns:r="http://schemas.openxmlformats.org/officeDocument/2006/relationships" xmlns:p1510="http://schemas.microsoft.com/office/powerpoint/2015/10/main">
   <p1510:revLst>
-    <p1510:client id="{DF2046C9-5CA7-6749-A58F-6F62A7ACF621}" v="38" dt="2025-11-11T20:28:27.254"/>
+    <p1510:client id="{DF2046C9-5CA7-6749-A58F-6F62A7ACF621}" v="43" dt="2025-11-13T09:51:38.804"/>
   </p1510:revLst>
 </p1510:revInfo>
 </file>
@@ -324,16 +324,24 @@
   <pc:docChgLst>
     <pc:chgData name="Ingo Frommholz" userId="ee3b4549-206f-4e4f-93a1-b7ff676f0af7" providerId="ADAL" clId="{5F8971C4-3D52-5FAB-A951-9912A46CDBB0}"/>
     <pc:docChg chg="modSld">
-      <pc:chgData name="Ingo Frommholz" userId="ee3b4549-206f-4e4f-93a1-b7ff676f0af7" providerId="ADAL" clId="{5F8971C4-3D52-5FAB-A951-9912A46CDBB0}" dt="2025-11-11T20:28:27.254" v="74"/>
+      <pc:chgData name="Ingo Frommholz" userId="ee3b4549-206f-4e4f-93a1-b7ff676f0af7" providerId="ADAL" clId="{5F8971C4-3D52-5FAB-A951-9912A46CDBB0}" dt="2025-11-13T09:51:38.804" v="81" actId="404"/>
       <pc:docMkLst>
         <pc:docMk/>
       </pc:docMkLst>
-      <pc:sldChg chg="modSp mod">
-        <pc:chgData name="Ingo Frommholz" userId="ee3b4549-206f-4e4f-93a1-b7ff676f0af7" providerId="ADAL" clId="{5F8971C4-3D52-5FAB-A951-9912A46CDBB0}" dt="2025-11-11T20:28:02.199" v="73" actId="1076"/>
+      <pc:sldChg chg="addSp delSp modSp mod">
+        <pc:chgData name="Ingo Frommholz" userId="ee3b4549-206f-4e4f-93a1-b7ff676f0af7" providerId="ADAL" clId="{5F8971C4-3D52-5FAB-A951-9912A46CDBB0}" dt="2025-11-13T09:31:11.111" v="77"/>
         <pc:sldMkLst>
           <pc:docMk/>
           <pc:sldMk cId="2688265821" sldId="461"/>
         </pc:sldMkLst>
+        <pc:spChg chg="add del mod">
+          <ac:chgData name="Ingo Frommholz" userId="ee3b4549-206f-4e4f-93a1-b7ff676f0af7" providerId="ADAL" clId="{5F8971C4-3D52-5FAB-A951-9912A46CDBB0}" dt="2025-11-13T09:31:11.111" v="77"/>
+          <ac:spMkLst>
+            <pc:docMk/>
+            <pc:sldMk cId="2688265821" sldId="461"/>
+            <ac:spMk id="3" creationId="{B0032EC6-54E9-E35F-1689-A685A366BF14}"/>
+          </ac:spMkLst>
+        </pc:spChg>
         <pc:spChg chg="mod">
           <ac:chgData name="Ingo Frommholz" userId="ee3b4549-206f-4e4f-93a1-b7ff676f0af7" providerId="ADAL" clId="{5F8971C4-3D52-5FAB-A951-9912A46CDBB0}" dt="2025-11-11T20:27:51.269" v="71" actId="1035"/>
           <ac:spMkLst>
@@ -397,7 +405,7 @@
         </pc:spChg>
       </pc:sldChg>
       <pc:sldChg chg="modSp modAnim">
-        <pc:chgData name="Ingo Frommholz" userId="ee3b4549-206f-4e4f-93a1-b7ff676f0af7" providerId="ADAL" clId="{5F8971C4-3D52-5FAB-A951-9912A46CDBB0}" dt="2025-11-11T20:25:50.273" v="34" actId="20577"/>
+        <pc:chgData name="Ingo Frommholz" userId="ee3b4549-206f-4e4f-93a1-b7ff676f0af7" providerId="ADAL" clId="{5F8971C4-3D52-5FAB-A951-9912A46CDBB0}" dt="2025-11-13T09:51:38.804" v="81" actId="404"/>
         <pc:sldMkLst>
           <pc:docMk/>
           <pc:sldMk cId="7853090" sldId="593"/>
@@ -408,6 +416,14 @@
             <pc:docMk/>
             <pc:sldMk cId="7853090" sldId="593"/>
             <ac:spMk id="8" creationId="{21A8D102-1C16-49D0-9B80-8EAB675A9A7B}"/>
+          </ac:spMkLst>
+        </pc:spChg>
+        <pc:spChg chg="mod">
+          <ac:chgData name="Ingo Frommholz" userId="ee3b4549-206f-4e4f-93a1-b7ff676f0af7" providerId="ADAL" clId="{5F8971C4-3D52-5FAB-A951-9912A46CDBB0}" dt="2025-11-13T09:51:38.804" v="81" actId="404"/>
+          <ac:spMkLst>
+            <pc:docMk/>
+            <pc:sldMk cId="7853090" sldId="593"/>
+            <ac:spMk id="9" creationId="{C28C4A5E-747D-470D-8354-D36B25F53E23}"/>
           </ac:spMkLst>
         </pc:spChg>
       </pc:sldChg>
@@ -31375,8 +31391,8 @@
           </a:p>
         </p:txBody>
       </p:sp>
-      <mc:AlternateContent xmlns:mc="http://schemas.openxmlformats.org/markup-compatibility/2006">
-        <mc:Choice xmlns:a14="http://schemas.microsoft.com/office/drawing/2010/main" Requires="a14">
+      <mc:AlternateContent xmlns:mc="http://schemas.openxmlformats.org/markup-compatibility/2006" xmlns:a14="http://schemas.microsoft.com/office/drawing/2010/main">
+        <mc:Choice Requires="a14">
           <p:sp>
             <p:nvSpPr>
               <p:cNvPr id="8" name="Google Shape;87;p2">
@@ -31832,7 +31848,7 @@
             </p:txBody>
           </p:sp>
         </mc:Choice>
-        <mc:Fallback>
+        <mc:Fallback xmlns="">
           <p:sp>
             <p:nvSpPr>
               <p:cNvPr id="8" name="Google Shape;87;p2">
@@ -32703,72 +32719,44 @@
               </a:spcBef>
             </a:pPr>
             <a:r>
-              <a:rPr lang="pt-BR" dirty="0">
+              <a:rPr lang="pt-BR" sz="1200" dirty="0">
                 <a:latin typeface="Consolas" panose="020B0609020204030204" pitchFamily="49" charset="0"/>
                 <a:ea typeface="Cambria Math" panose="02040503050406030204" pitchFamily="18" charset="0"/>
                 <a:cs typeface="Calibri" panose="020F0502020204030204" pitchFamily="34" charset="0"/>
               </a:rPr>
-              <a:t># Iterative with for</a:t>
-            </a:r>
-          </a:p>
-          <a:p>
-            <a:pPr marL="0" lvl="0" indent="0">
-              <a:spcBef>
-                <a:spcPts val="640"/>
-              </a:spcBef>
-            </a:pPr>
-            <a:r>
-              <a:rPr lang="pt-BR" dirty="0">
+              <a:t># </a:t>
+            </a:r>
+            <a:r>
+              <a:rPr lang="pt-BR" sz="1200" dirty="0" err="1">
                 <a:latin typeface="Consolas" panose="020B0609020204030204" pitchFamily="49" charset="0"/>
                 <a:ea typeface="Cambria Math" panose="02040503050406030204" pitchFamily="18" charset="0"/>
                 <a:cs typeface="Calibri" panose="020F0502020204030204" pitchFamily="34" charset="0"/>
               </a:rPr>
-              <a:t>def fib(n):</a:t>
-            </a:r>
-          </a:p>
-          <a:p>
-            <a:pPr marL="0" lvl="0" indent="0">
-              <a:spcBef>
-                <a:spcPts val="640"/>
-              </a:spcBef>
-            </a:pPr>
-            <a:r>
-              <a:rPr lang="pt-BR" dirty="0">
+              <a:t>Iterative</a:t>
+            </a:r>
+            <a:r>
+              <a:rPr lang="pt-BR" sz="1200" dirty="0">
                 <a:latin typeface="Consolas" panose="020B0609020204030204" pitchFamily="49" charset="0"/>
                 <a:ea typeface="Cambria Math" panose="02040503050406030204" pitchFamily="18" charset="0"/>
                 <a:cs typeface="Calibri" panose="020F0502020204030204" pitchFamily="34" charset="0"/>
               </a:rPr>
-              <a:t>    num_1 = 0</a:t>
-            </a:r>
-          </a:p>
-          <a:p>
-            <a:pPr marL="0" lvl="0" indent="0">
-              <a:spcBef>
-                <a:spcPts val="640"/>
-              </a:spcBef>
-            </a:pPr>
-            <a:r>
-              <a:rPr lang="pt-BR" dirty="0">
+              <a:t> </a:t>
+            </a:r>
+            <a:r>
+              <a:rPr lang="pt-BR" sz="1200" dirty="0" err="1">
                 <a:latin typeface="Consolas" panose="020B0609020204030204" pitchFamily="49" charset="0"/>
                 <a:ea typeface="Cambria Math" panose="02040503050406030204" pitchFamily="18" charset="0"/>
                 <a:cs typeface="Calibri" panose="020F0502020204030204" pitchFamily="34" charset="0"/>
               </a:rPr>
-              <a:t>    num_2 = 1</a:t>
-            </a:r>
-          </a:p>
-          <a:p>
-            <a:pPr marL="0" lvl="0" indent="0">
-              <a:spcBef>
-                <a:spcPts val="640"/>
-              </a:spcBef>
-            </a:pPr>
-            <a:r>
-              <a:rPr lang="pt-BR" dirty="0">
+              <a:t>with</a:t>
+            </a:r>
+            <a:r>
+              <a:rPr lang="pt-BR" sz="1200" dirty="0">
                 <a:latin typeface="Consolas" panose="020B0609020204030204" pitchFamily="49" charset="0"/>
                 <a:ea typeface="Cambria Math" panose="02040503050406030204" pitchFamily="18" charset="0"/>
                 <a:cs typeface="Calibri" panose="020F0502020204030204" pitchFamily="34" charset="0"/>
               </a:rPr>
-              <a:t>    for i in range(0, n):</a:t>
+              <a:t> for</a:t>
             </a:r>
           </a:p>
           <a:p>
@@ -32778,42 +32766,181 @@
               </a:spcBef>
             </a:pPr>
             <a:r>
-              <a:rPr lang="pt-BR" dirty="0">
+              <a:rPr lang="pt-BR" sz="1200" dirty="0" err="1">
                 <a:latin typeface="Consolas" panose="020B0609020204030204" pitchFamily="49" charset="0"/>
                 <a:ea typeface="Cambria Math" panose="02040503050406030204" pitchFamily="18" charset="0"/>
                 <a:cs typeface="Calibri" panose="020F0502020204030204" pitchFamily="34" charset="0"/>
               </a:rPr>
-              <a:t>        num_1 = num_2</a:t>
-            </a:r>
-          </a:p>
-          <a:p>
-            <a:pPr marL="0" lvl="0" indent="0">
-              <a:spcBef>
-                <a:spcPts val="640"/>
-              </a:spcBef>
-            </a:pPr>
-            <a:r>
-              <a:rPr lang="pt-BR" dirty="0">
+              <a:t>def</a:t>
+            </a:r>
+            <a:r>
+              <a:rPr lang="pt-BR" sz="1200" dirty="0">
                 <a:latin typeface="Consolas" panose="020B0609020204030204" pitchFamily="49" charset="0"/>
                 <a:ea typeface="Cambria Math" panose="02040503050406030204" pitchFamily="18" charset="0"/>
                 <a:cs typeface="Calibri" panose="020F0502020204030204" pitchFamily="34" charset="0"/>
               </a:rPr>
-              <a:t>        num_2 = num_1+num_2</a:t>
-            </a:r>
-          </a:p>
-          <a:p>
-            <a:pPr marL="0" lvl="0" indent="0">
-              <a:spcBef>
-                <a:spcPts val="640"/>
-              </a:spcBef>
-            </a:pPr>
-            <a:r>
-              <a:rPr lang="pt-BR" dirty="0">
+              <a:t> </a:t>
+            </a:r>
+            <a:r>
+              <a:rPr lang="pt-BR" sz="1200" dirty="0" err="1">
                 <a:latin typeface="Consolas" panose="020B0609020204030204" pitchFamily="49" charset="0"/>
                 <a:ea typeface="Cambria Math" panose="02040503050406030204" pitchFamily="18" charset="0"/>
                 <a:cs typeface="Calibri" panose="020F0502020204030204" pitchFamily="34" charset="0"/>
               </a:rPr>
-              <a:t>    return num_1</a:t>
+              <a:t>fib_for</a:t>
+            </a:r>
+            <a:r>
+              <a:rPr lang="pt-BR" sz="1200" dirty="0">
+                <a:latin typeface="Consolas" panose="020B0609020204030204" pitchFamily="49" charset="0"/>
+                <a:ea typeface="Cambria Math" panose="02040503050406030204" pitchFamily="18" charset="0"/>
+                <a:cs typeface="Calibri" panose="020F0502020204030204" pitchFamily="34" charset="0"/>
+              </a:rPr>
+              <a:t>(</a:t>
+            </a:r>
+            <a:r>
+              <a:rPr lang="pt-BR" sz="1200" dirty="0" err="1">
+                <a:latin typeface="Consolas" panose="020B0609020204030204" pitchFamily="49" charset="0"/>
+                <a:ea typeface="Cambria Math" panose="02040503050406030204" pitchFamily="18" charset="0"/>
+                <a:cs typeface="Calibri" panose="020F0502020204030204" pitchFamily="34" charset="0"/>
+              </a:rPr>
+              <a:t>n</a:t>
+            </a:r>
+            <a:r>
+              <a:rPr lang="pt-BR" sz="1200" dirty="0">
+                <a:latin typeface="Consolas" panose="020B0609020204030204" pitchFamily="49" charset="0"/>
+                <a:ea typeface="Cambria Math" panose="02040503050406030204" pitchFamily="18" charset="0"/>
+                <a:cs typeface="Calibri" panose="020F0502020204030204" pitchFamily="34" charset="0"/>
+              </a:rPr>
+              <a:t>):</a:t>
+            </a:r>
+          </a:p>
+          <a:p>
+            <a:pPr marL="0" lvl="0" indent="0">
+              <a:spcBef>
+                <a:spcPts val="640"/>
+              </a:spcBef>
+            </a:pPr>
+            <a:r>
+              <a:rPr lang="pt-BR" sz="1200" dirty="0">
+                <a:latin typeface="Consolas" panose="020B0609020204030204" pitchFamily="49" charset="0"/>
+                <a:ea typeface="Cambria Math" panose="02040503050406030204" pitchFamily="18" charset="0"/>
+                <a:cs typeface="Calibri" panose="020F0502020204030204" pitchFamily="34" charset="0"/>
+              </a:rPr>
+              <a:t>    num_1 = 0</a:t>
+            </a:r>
+          </a:p>
+          <a:p>
+            <a:pPr marL="0" lvl="0" indent="0">
+              <a:spcBef>
+                <a:spcPts val="640"/>
+              </a:spcBef>
+            </a:pPr>
+            <a:r>
+              <a:rPr lang="pt-BR" sz="1200" dirty="0">
+                <a:latin typeface="Consolas" panose="020B0609020204030204" pitchFamily="49" charset="0"/>
+                <a:ea typeface="Cambria Math" panose="02040503050406030204" pitchFamily="18" charset="0"/>
+                <a:cs typeface="Calibri" panose="020F0502020204030204" pitchFamily="34" charset="0"/>
+              </a:rPr>
+              <a:t>    num_2 = 1</a:t>
+            </a:r>
+          </a:p>
+          <a:p>
+            <a:pPr marL="0" lvl="0" indent="0">
+              <a:spcBef>
+                <a:spcPts val="640"/>
+              </a:spcBef>
+            </a:pPr>
+            <a:r>
+              <a:rPr lang="pt-BR" sz="1200" dirty="0">
+                <a:latin typeface="Consolas" panose="020B0609020204030204" pitchFamily="49" charset="0"/>
+                <a:ea typeface="Cambria Math" panose="02040503050406030204" pitchFamily="18" charset="0"/>
+                <a:cs typeface="Calibri" panose="020F0502020204030204" pitchFamily="34" charset="0"/>
+              </a:rPr>
+              <a:t>    for </a:t>
+            </a:r>
+            <a:r>
+              <a:rPr lang="pt-BR" sz="1200" dirty="0" err="1">
+                <a:latin typeface="Consolas" panose="020B0609020204030204" pitchFamily="49" charset="0"/>
+                <a:ea typeface="Cambria Math" panose="02040503050406030204" pitchFamily="18" charset="0"/>
+                <a:cs typeface="Calibri" panose="020F0502020204030204" pitchFamily="34" charset="0"/>
+              </a:rPr>
+              <a:t>i</a:t>
+            </a:r>
+            <a:r>
+              <a:rPr lang="pt-BR" sz="1200" dirty="0">
+                <a:latin typeface="Consolas" panose="020B0609020204030204" pitchFamily="49" charset="0"/>
+                <a:ea typeface="Cambria Math" panose="02040503050406030204" pitchFamily="18" charset="0"/>
+                <a:cs typeface="Calibri" panose="020F0502020204030204" pitchFamily="34" charset="0"/>
+              </a:rPr>
+              <a:t> in range(0, n-1):</a:t>
+            </a:r>
+          </a:p>
+          <a:p>
+            <a:pPr marL="0" lvl="0" indent="0">
+              <a:spcBef>
+                <a:spcPts val="640"/>
+              </a:spcBef>
+            </a:pPr>
+            <a:r>
+              <a:rPr lang="pt-BR" sz="1200" dirty="0">
+                <a:latin typeface="Consolas" panose="020B0609020204030204" pitchFamily="49" charset="0"/>
+                <a:ea typeface="Cambria Math" panose="02040503050406030204" pitchFamily="18" charset="0"/>
+                <a:cs typeface="Calibri" panose="020F0502020204030204" pitchFamily="34" charset="0"/>
+              </a:rPr>
+              <a:t>        num_1_old = num_1</a:t>
+            </a:r>
+          </a:p>
+          <a:p>
+            <a:pPr marL="0" lvl="0" indent="0">
+              <a:spcBef>
+                <a:spcPts val="640"/>
+              </a:spcBef>
+            </a:pPr>
+            <a:r>
+              <a:rPr lang="pt-BR" sz="1200" dirty="0">
+                <a:latin typeface="Consolas" panose="020B0609020204030204" pitchFamily="49" charset="0"/>
+                <a:ea typeface="Cambria Math" panose="02040503050406030204" pitchFamily="18" charset="0"/>
+                <a:cs typeface="Calibri" panose="020F0502020204030204" pitchFamily="34" charset="0"/>
+              </a:rPr>
+              <a:t>        num_1 = num_2</a:t>
+            </a:r>
+          </a:p>
+          <a:p>
+            <a:pPr marL="0" lvl="0" indent="0">
+              <a:spcBef>
+                <a:spcPts val="640"/>
+              </a:spcBef>
+            </a:pPr>
+            <a:r>
+              <a:rPr lang="pt-BR" sz="1200" dirty="0">
+                <a:latin typeface="Consolas" panose="020B0609020204030204" pitchFamily="49" charset="0"/>
+                <a:ea typeface="Cambria Math" panose="02040503050406030204" pitchFamily="18" charset="0"/>
+                <a:cs typeface="Calibri" panose="020F0502020204030204" pitchFamily="34" charset="0"/>
+              </a:rPr>
+              <a:t>        num_2 = num_1_old + num_2</a:t>
+            </a:r>
+          </a:p>
+          <a:p>
+            <a:pPr marL="0" lvl="0" indent="0">
+              <a:spcBef>
+                <a:spcPts val="640"/>
+              </a:spcBef>
+            </a:pPr>
+            <a:r>
+              <a:rPr lang="pt-BR" sz="1200" dirty="0" err="1">
+                <a:latin typeface="Consolas" panose="020B0609020204030204" pitchFamily="49" charset="0"/>
+                <a:ea typeface="Cambria Math" panose="02040503050406030204" pitchFamily="18" charset="0"/>
+                <a:cs typeface="Calibri" panose="020F0502020204030204" pitchFamily="34" charset="0"/>
+              </a:rPr>
+              <a:t>return</a:t>
+            </a:r>
+            <a:r>
+              <a:rPr lang="pt-BR" sz="1200" dirty="0">
+                <a:latin typeface="Consolas" panose="020B0609020204030204" pitchFamily="49" charset="0"/>
+                <a:ea typeface="Cambria Math" panose="02040503050406030204" pitchFamily="18" charset="0"/>
+                <a:cs typeface="Calibri" panose="020F0502020204030204" pitchFamily="34" charset="0"/>
+              </a:rPr>
+              <a:t> num_1</a:t>
             </a:r>
           </a:p>
         </p:txBody>

</xml_diff>